<commit_message>
docs: horas de evolucao na proposta (pacote de 20h ou hora avulsa)
Deixa explicito que o pacote mensal de R$ 1.875,00 traz 20 horas para
melhorias, o que da R$ 93,75 a hora efetiva, e abre a alternativa de
contratar por demanda a R$ 150,00/hora para quem usa pouco. Ponto de
equilibrio em 12,5 horas por mes.

Alinha tambem o Modelo 1, que prometia 'evolucoes continuas incluidas'
sem limite por R$ 1.980/mes enquanto a manutencao pos-aquisicao dava
20h por R$ 1.875/mes. Agora os dois modelos usam o mesmo criterio de
20 horas mensais, e a diferenca de preco fica sendo a infraestrutura.

PPTX passa a 22 slides, com o slide de horas apos 'Assinar ou adquirir'.

Co-Authored-By: Claude Opus 5 <noreply@anthropic.com>
</commit_message>
<xml_diff>
--- a/docs/Proposta-Comercial-Operacao-GpsTecRS.pptx
+++ b/docs/Proposta-Comercial-Operacao-GpsTecRS.pptx
@@ -22,6 +22,7 @@
     <p:sldId id="270" r:id="rId16"/>
     <p:sldId id="271" r:id="rId17"/>
     <p:sldId id="272" r:id="rId18"/>
+    <p:sldId id="277" r:id="rId28"/>
     <p:sldId id="273" r:id="rId19"/>
     <p:sldId id="275" r:id="rId26"/>
     <p:sldId id="276" r:id="rId27"/>
@@ -3591,7 +3592,7 @@
                 <a:ea typeface="Calibri" pitchFamily="34" charset="-122"/>
                 <a:cs typeface="Calibri" pitchFamily="34" charset="-120"/>
               </a:rPr>
-              <a:t>A ARV LABS mantém a plataforma no ar, com hospedagem, backup, suporte, correções e evoluções incluídas.</a:t>
+              <a:t>A ARV LABS mantém a plataforma no ar: hospedagem, backup, suporte, correções de segurança e 20 horas mensais de evolução inclusas.</a:t>
             </a:r>
             <a:endParaRPr lang="en-US" sz="1300" dirty="0"/>
           </a:p>
@@ -7402,7 +7403,7 @@
                 <a:ea typeface="Calibri" pitchFamily="34" charset="-122"/>
                 <a:cs typeface="Calibri" pitchFamily="34" charset="-120"/>
               </a:rPr>
-              <a:t>por ano  ·  R$ 1.875,00/mês</a:t>
+              <a:t>por ano  ·  R$ 1.875,00/mês  ·  R$ 93,75 a hora</a:t>
             </a:r>
             <a:endParaRPr lang="en-US" sz="1150" dirty="0"/>
           </a:p>
@@ -7445,7 +7446,7 @@
                 <a:ea typeface="Calibri" pitchFamily="34" charset="-122"/>
                 <a:cs typeface="Calibri" pitchFamily="34" charset="-120"/>
               </a:rPr>
-              <a:t>Correções e atualizações de segurança</a:t>
+              <a:t>20 horas por mês para melhorias e evoluções</a:t>
             </a:r>
             <a:endParaRPr lang="en-US" sz="1100" dirty="0"/>
           </a:p>
@@ -7466,7 +7467,7 @@
                 <a:ea typeface="Calibri" pitchFamily="34" charset="-122"/>
                 <a:cs typeface="Calibri" pitchFamily="34" charset="-120"/>
               </a:rPr>
-              <a:t>Suporte técnico em horário comercial</a:t>
+              <a:t>Correções de segurança, sem consumir horas</a:t>
             </a:r>
             <a:endParaRPr lang="en-US" sz="1100" dirty="0"/>
           </a:p>
@@ -7487,7 +7488,7 @@
                 <a:ea typeface="Calibri" pitchFamily="34" charset="-122"/>
                 <a:cs typeface="Calibri" pitchFamily="34" charset="-120"/>
               </a:rPr>
-              <a:t>Banco de horas para melhorias (20h/mês)</a:t>
+              <a:t>Suporte técnico em horário comercial</a:t>
             </a:r>
             <a:endParaRPr lang="en-US" sz="1100" dirty="0"/>
           </a:p>
@@ -13488,6 +13489,1466 @@
               <a:t> e podem ser exportados a qualquer momento, em formato aberto, sem custo e sem carência.</a:t>
             </a:r>
             <a:endParaRPr lang="en-US" sz="1200" dirty="0"/>
+          </a:p>
+        </p:txBody>
+      </p:sp>
+    </p:spTree>
+  </p:cSld>
+  <p:clrMapOvr>
+    <a:masterClrMapping/>
+  </p:clrMapOvr>
+</p:sld>
+</file>
+
+<file path=ppt/slides/slide22.xml><?xml version="1.0" encoding="utf-8"?>
+<p:sld xmlns:a="http://schemas.openxmlformats.org/drawingml/2006/main" xmlns:r="http://schemas.openxmlformats.org/officeDocument/2006/relationships" xmlns:p="http://schemas.openxmlformats.org/presentationml/2006/main">
+  <p:cSld name="Slide 1">
+    <p:bg>
+      <p:bgPr>
+        <a:solidFill>
+          <a:srgbClr val="EEF1F5"/>
+        </a:solidFill>
+      </p:bgPr>
+    </p:bg>
+    <p:spTree>
+      <p:nvGrpSpPr>
+        <p:cNvPr id="1" name=""/>
+        <p:cNvGrpSpPr/>
+        <p:nvPr/>
+      </p:nvGrpSpPr>
+      <p:grpSpPr>
+        <a:xfrm>
+          <a:off x="0" y="0"/>
+          <a:ext cx="0" cy="0"/>
+          <a:chOff x="0" y="0"/>
+          <a:chExt cx="0" cy="0"/>
+        </a:xfrm>
+      </p:grpSpPr>
+      <p:sp>
+        <p:nvSpPr>
+          <p:cNvPr id="2" name="Text 0"/>
+          <p:cNvSpPr/>
+          <p:nvPr/>
+        </p:nvSpPr>
+        <p:spPr>
+          <a:xfrm>
+            <a:off x="548640" y="384048"/>
+            <a:ext cx="11094415" cy="548640"/>
+          </a:xfrm>
+          <a:prstGeom prst="rect">
+            <a:avLst/>
+          </a:prstGeom>
+          <a:noFill/>
+          <a:ln/>
+        </p:spPr>
+        <p:txBody>
+          <a:bodyPr wrap="square" rtlCol="0" anchor="ctr"/>
+          <a:lstStyle/>
+          <a:p>
+            <a:pPr indent="0" marL="0">
+              <a:buNone/>
+            </a:pPr>
+            <a:r>
+              <a:rPr lang="en-US" sz="3000" b="1" dirty="0">
+                <a:solidFill>
+                  <a:srgbClr val="101828"/>
+                </a:solidFill>
+                <a:latin typeface="Cambria" pitchFamily="34" charset="0"/>
+                <a:ea typeface="Cambria" pitchFamily="34" charset="-122"/>
+                <a:cs typeface="Cambria" pitchFamily="34" charset="-120"/>
+              </a:rPr>
+              <a:t>Horas de evolução</a:t>
+            </a:r>
+            <a:endParaRPr lang="en-US" sz="3000" dirty="0"/>
+          </a:p>
+        </p:txBody>
+      </p:sp>
+      <p:sp>
+        <p:nvSpPr>
+          <p:cNvPr id="3" name="Text 1"/>
+          <p:cNvSpPr/>
+          <p:nvPr/>
+        </p:nvSpPr>
+        <p:spPr>
+          <a:xfrm>
+            <a:off x="548640" y="960120"/>
+            <a:ext cx="11094415" cy="384048"/>
+          </a:xfrm>
+          <a:prstGeom prst="rect">
+            <a:avLst/>
+          </a:prstGeom>
+          <a:noFill/>
+          <a:ln/>
+        </p:spPr>
+        <p:txBody>
+          <a:bodyPr wrap="square" rtlCol="0" anchor="ctr"/>
+          <a:lstStyle/>
+          <a:p>
+            <a:pPr indent="0" marL="0">
+              <a:buNone/>
+            </a:pPr>
+            <a:r>
+              <a:rPr lang="en-US" sz="1300" dirty="0">
+                <a:solidFill>
+                  <a:srgbClr val="64748B"/>
+                </a:solidFill>
+                <a:latin typeface="Calibri" pitchFamily="34" charset="0"/>
+                <a:ea typeface="Calibri" pitchFamily="34" charset="-122"/>
+                <a:cs typeface="Calibri" pitchFamily="34" charset="-120"/>
+              </a:rPr>
+              <a:t>Melhorias e evoluções consomem horas de desenvolvimento. A GPSTec escolhe entre o pacote fechado e a contratação por demanda.</a:t>
+            </a:r>
+            <a:endParaRPr lang="en-US" sz="1300" dirty="0"/>
+          </a:p>
+        </p:txBody>
+      </p:sp>
+      <p:graphicFrame>
+        <p:nvGraphicFramePr>
+          <p:cNvPr id="2" name="Table 0"/>
+          <p:cNvGraphicFramePr>
+            <a:graphicFrameLocks noGrp="1"/>
+          </p:cNvGraphicFramePr>
+          <p:nvPr>
+            <p:extLst>
+              <p:ext uri="{D42A27DB-BD31-4B8C-83A1-F6EECF244321}">
+                <p14:modId xmlns:p14="http://schemas.microsoft.com/office/powerpoint/2010/main" val="1579011935"/>
+              </p:ext>
+            </p:extLst>
+          </p:nvPr>
+        </p:nvGraphicFramePr>
+        <p:xfrm>
+          <a:off x="548640" y="1517904"/>
+          <a:ext cx="11094415" cy="914400"/>
+        </p:xfrm>
+        <a:graphic>
+          <a:graphicData uri="http://schemas.openxmlformats.org/drawingml/2006/table">
+            <a:tbl>
+              <a:tblPr/>
+              <a:tblGrid>
+                <a:gridCol w="3566160"/>
+                <a:gridCol w="2377440"/>
+                <a:gridCol w="2103120"/>
+                <a:gridCol w="3044952"/>
+              </a:tblGrid>
+              <a:tr h="329184">
+                <a:tc>
+                  <a:txBody>
+                    <a:bodyPr/>
+                    <a:lstStyle/>
+                    <a:p>
+                      <a:pPr algn="ctr" indent="0" marL="0">
+                        <a:buNone/>
+                      </a:pPr>
+                      <a:r>
+                        <a:rPr lang="en-US" sz="1050" b="1" dirty="0">
+                          <a:solidFill>
+                            <a:srgbClr val="64748B"/>
+                          </a:solidFill>
+                          <a:latin typeface="Calibri" pitchFamily="34" charset="0"/>
+                          <a:ea typeface="Calibri" pitchFamily="34" charset="-122"/>
+                          <a:cs typeface="Calibri" pitchFamily="34" charset="-120"/>
+                        </a:rPr>
+                        <a:t>FORMA DE CONTRATAÇÃO</a:t>
+                      </a:r>
+                      <a:endParaRPr lang="en-US" sz="1050" dirty="0">
+                        <a:latin typeface="Calibri" charset="0"/>
+                        <a:ea typeface="Calibri" charset="0"/>
+                        <a:cs typeface="Calibri" charset="0"/>
+                      </a:endParaRPr>
+                    </a:p>
+                  </a:txBody>
+                  <a:tcPr marL="91440" marR="91440" marT="91440" marB="91440" anchor="ctr">
+                    <a:lnL w="12700" cap="flat" cmpd="sng" algn="ctr">
+                      <a:solidFill>
+                        <a:srgbClr val="E2E8F0"/>
+                      </a:solidFill>
+                      <a:prstDash val="solid"/>
+                      <a:round/>
+                      <a:headEnd type="none" w="med" len="med"/>
+                      <a:tailEnd type="none" w="med" len="med"/>
+                    </a:lnL>
+                    <a:lnR w="12700" cap="flat" cmpd="sng" algn="ctr">
+                      <a:solidFill>
+                        <a:srgbClr val="E2E8F0"/>
+                      </a:solidFill>
+                      <a:prstDash val="solid"/>
+                      <a:round/>
+                      <a:headEnd type="none" w="med" len="med"/>
+                      <a:tailEnd type="none" w="med" len="med"/>
+                    </a:lnR>
+                    <a:lnT w="12700" cap="flat" cmpd="sng" algn="ctr">
+                      <a:solidFill>
+                        <a:srgbClr val="E2E8F0"/>
+                      </a:solidFill>
+                      <a:prstDash val="solid"/>
+                      <a:round/>
+                      <a:headEnd type="none" w="med" len="med"/>
+                      <a:tailEnd type="none" w="med" len="med"/>
+                    </a:lnT>
+                    <a:lnB w="12700" cap="flat" cmpd="sng" algn="ctr">
+                      <a:solidFill>
+                        <a:srgbClr val="E2E8F0"/>
+                      </a:solidFill>
+                      <a:prstDash val="solid"/>
+                      <a:round/>
+                      <a:headEnd type="none" w="med" len="med"/>
+                      <a:tailEnd type="none" w="med" len="med"/>
+                    </a:lnB>
+                    <a:solidFill>
+                      <a:srgbClr val="F8FAFC"/>
+                    </a:solidFill>
+                  </a:tcPr>
+                </a:tc>
+                <a:tc>
+                  <a:txBody>
+                    <a:bodyPr/>
+                    <a:lstStyle/>
+                    <a:p>
+                      <a:pPr algn="ctr" indent="0" marL="0">
+                        <a:buNone/>
+                      </a:pPr>
+                      <a:r>
+                        <a:rPr lang="en-US" sz="1050" b="1" dirty="0">
+                          <a:solidFill>
+                            <a:srgbClr val="64748B"/>
+                          </a:solidFill>
+                          <a:latin typeface="Calibri" pitchFamily="34" charset="0"/>
+                          <a:ea typeface="Calibri" pitchFamily="34" charset="-122"/>
+                          <a:cs typeface="Calibri" pitchFamily="34" charset="-120"/>
+                        </a:rPr>
+                        <a:t>VALOR</a:t>
+                      </a:r>
+                      <a:endParaRPr lang="en-US" sz="1050" dirty="0">
+                        <a:latin typeface="Calibri" charset="0"/>
+                        <a:ea typeface="Calibri" charset="0"/>
+                        <a:cs typeface="Calibri" charset="0"/>
+                      </a:endParaRPr>
+                    </a:p>
+                  </a:txBody>
+                  <a:tcPr marL="91440" marR="91440" marT="91440" marB="91440" anchor="ctr">
+                    <a:lnL w="12700" cap="flat" cmpd="sng" algn="ctr">
+                      <a:solidFill>
+                        <a:srgbClr val="E2E8F0"/>
+                      </a:solidFill>
+                      <a:prstDash val="solid"/>
+                      <a:round/>
+                      <a:headEnd type="none" w="med" len="med"/>
+                      <a:tailEnd type="none" w="med" len="med"/>
+                    </a:lnL>
+                    <a:lnR w="12700" cap="flat" cmpd="sng" algn="ctr">
+                      <a:solidFill>
+                        <a:srgbClr val="E2E8F0"/>
+                      </a:solidFill>
+                      <a:prstDash val="solid"/>
+                      <a:round/>
+                      <a:headEnd type="none" w="med" len="med"/>
+                      <a:tailEnd type="none" w="med" len="med"/>
+                    </a:lnR>
+                    <a:lnT w="12700" cap="flat" cmpd="sng" algn="ctr">
+                      <a:solidFill>
+                        <a:srgbClr val="E2E8F0"/>
+                      </a:solidFill>
+                      <a:prstDash val="solid"/>
+                      <a:round/>
+                      <a:headEnd type="none" w="med" len="med"/>
+                      <a:tailEnd type="none" w="med" len="med"/>
+                    </a:lnT>
+                    <a:lnB w="12700" cap="flat" cmpd="sng" algn="ctr">
+                      <a:solidFill>
+                        <a:srgbClr val="E2E8F0"/>
+                      </a:solidFill>
+                      <a:prstDash val="solid"/>
+                      <a:round/>
+                      <a:headEnd type="none" w="med" len="med"/>
+                      <a:tailEnd type="none" w="med" len="med"/>
+                    </a:lnB>
+                    <a:solidFill>
+                      <a:srgbClr val="F8FAFC"/>
+                    </a:solidFill>
+                  </a:tcPr>
+                </a:tc>
+                <a:tc>
+                  <a:txBody>
+                    <a:bodyPr/>
+                    <a:lstStyle/>
+                    <a:p>
+                      <a:pPr algn="ctr" indent="0" marL="0">
+                        <a:buNone/>
+                      </a:pPr>
+                      <a:r>
+                        <a:rPr lang="en-US" sz="1050" b="1" dirty="0">
+                          <a:solidFill>
+                            <a:srgbClr val="64748B"/>
+                          </a:solidFill>
+                          <a:latin typeface="Calibri" pitchFamily="34" charset="0"/>
+                          <a:ea typeface="Calibri" pitchFamily="34" charset="-122"/>
+                          <a:cs typeface="Calibri" pitchFamily="34" charset="-120"/>
+                        </a:rPr>
+                        <a:t>HORA EFETIVA</a:t>
+                      </a:r>
+                      <a:endParaRPr lang="en-US" sz="1050" dirty="0">
+                        <a:latin typeface="Calibri" charset="0"/>
+                        <a:ea typeface="Calibri" charset="0"/>
+                        <a:cs typeface="Calibri" charset="0"/>
+                      </a:endParaRPr>
+                    </a:p>
+                  </a:txBody>
+                  <a:tcPr marL="91440" marR="91440" marT="91440" marB="91440" anchor="ctr">
+                    <a:lnL w="12700" cap="flat" cmpd="sng" algn="ctr">
+                      <a:solidFill>
+                        <a:srgbClr val="E2E8F0"/>
+                      </a:solidFill>
+                      <a:prstDash val="solid"/>
+                      <a:round/>
+                      <a:headEnd type="none" w="med" len="med"/>
+                      <a:tailEnd type="none" w="med" len="med"/>
+                    </a:lnL>
+                    <a:lnR w="12700" cap="flat" cmpd="sng" algn="ctr">
+                      <a:solidFill>
+                        <a:srgbClr val="E2E8F0"/>
+                      </a:solidFill>
+                      <a:prstDash val="solid"/>
+                      <a:round/>
+                      <a:headEnd type="none" w="med" len="med"/>
+                      <a:tailEnd type="none" w="med" len="med"/>
+                    </a:lnR>
+                    <a:lnT w="12700" cap="flat" cmpd="sng" algn="ctr">
+                      <a:solidFill>
+                        <a:srgbClr val="E2E8F0"/>
+                      </a:solidFill>
+                      <a:prstDash val="solid"/>
+                      <a:round/>
+                      <a:headEnd type="none" w="med" len="med"/>
+                      <a:tailEnd type="none" w="med" len="med"/>
+                    </a:lnT>
+                    <a:lnB w="12700" cap="flat" cmpd="sng" algn="ctr">
+                      <a:solidFill>
+                        <a:srgbClr val="E2E8F0"/>
+                      </a:solidFill>
+                      <a:prstDash val="solid"/>
+                      <a:round/>
+                      <a:headEnd type="none" w="med" len="med"/>
+                      <a:tailEnd type="none" w="med" len="med"/>
+                    </a:lnB>
+                    <a:solidFill>
+                      <a:srgbClr val="F8FAFC"/>
+                    </a:solidFill>
+                  </a:tcPr>
+                </a:tc>
+                <a:tc>
+                  <a:txBody>
+                    <a:bodyPr/>
+                    <a:lstStyle/>
+                    <a:p>
+                      <a:pPr algn="ctr" indent="0" marL="0">
+                        <a:buNone/>
+                      </a:pPr>
+                      <a:r>
+                        <a:rPr lang="en-US" sz="1050" b="1" dirty="0">
+                          <a:solidFill>
+                            <a:srgbClr val="64748B"/>
+                          </a:solidFill>
+                          <a:latin typeface="Calibri" pitchFamily="34" charset="0"/>
+                          <a:ea typeface="Calibri" pitchFamily="34" charset="-122"/>
+                          <a:cs typeface="Calibri" pitchFamily="34" charset="-120"/>
+                        </a:rPr>
+                        <a:t>QUANDO COMPENSA</a:t>
+                      </a:r>
+                      <a:endParaRPr lang="en-US" sz="1050" dirty="0">
+                        <a:latin typeface="Calibri" charset="0"/>
+                        <a:ea typeface="Calibri" charset="0"/>
+                        <a:cs typeface="Calibri" charset="0"/>
+                      </a:endParaRPr>
+                    </a:p>
+                  </a:txBody>
+                  <a:tcPr marL="91440" marR="91440" marT="91440" marB="91440" anchor="ctr">
+                    <a:lnL w="12700" cap="flat" cmpd="sng" algn="ctr">
+                      <a:solidFill>
+                        <a:srgbClr val="E2E8F0"/>
+                      </a:solidFill>
+                      <a:prstDash val="solid"/>
+                      <a:round/>
+                      <a:headEnd type="none" w="med" len="med"/>
+                      <a:tailEnd type="none" w="med" len="med"/>
+                    </a:lnL>
+                    <a:lnR w="12700" cap="flat" cmpd="sng" algn="ctr">
+                      <a:solidFill>
+                        <a:srgbClr val="E2E8F0"/>
+                      </a:solidFill>
+                      <a:prstDash val="solid"/>
+                      <a:round/>
+                      <a:headEnd type="none" w="med" len="med"/>
+                      <a:tailEnd type="none" w="med" len="med"/>
+                    </a:lnR>
+                    <a:lnT w="12700" cap="flat" cmpd="sng" algn="ctr">
+                      <a:solidFill>
+                        <a:srgbClr val="E2E8F0"/>
+                      </a:solidFill>
+                      <a:prstDash val="solid"/>
+                      <a:round/>
+                      <a:headEnd type="none" w="med" len="med"/>
+                      <a:tailEnd type="none" w="med" len="med"/>
+                    </a:lnT>
+                    <a:lnB w="12700" cap="flat" cmpd="sng" algn="ctr">
+                      <a:solidFill>
+                        <a:srgbClr val="E2E8F0"/>
+                      </a:solidFill>
+                      <a:prstDash val="solid"/>
+                      <a:round/>
+                      <a:headEnd type="none" w="med" len="med"/>
+                      <a:tailEnd type="none" w="med" len="med"/>
+                    </a:lnB>
+                    <a:solidFill>
+                      <a:srgbClr val="F8FAFC"/>
+                    </a:solidFill>
+                  </a:tcPr>
+                </a:tc>
+              </a:tr>
+              <a:tr h="713232">
+                <a:tc>
+                  <a:txBody>
+                    <a:bodyPr/>
+                    <a:lstStyle/>
+                    <a:p>
+                      <a:pPr algn="l" indent="0" marL="0">
+                        <a:buNone/>
+                      </a:pPr>
+                      <a:r>
+                        <a:rPr lang="en-US" sz="1250" b="1" dirty="0">
+                          <a:solidFill>
+                            <a:srgbClr val="101828"/>
+                          </a:solidFill>
+                          <a:latin typeface="Calibri" pitchFamily="34" charset="0"/>
+                          <a:ea typeface="Calibri" pitchFamily="34" charset="-122"/>
+                          <a:cs typeface="Calibri" pitchFamily="34" charset="-120"/>
+                        </a:rPr>
+                        <a:t>Pacote mensal
+</a:t>
+                      </a:r>
+                      <a:pPr algn="l" indent="0" marL="0">
+                        <a:buNone/>
+                      </a:pPr>
+                      <a:r>
+                        <a:rPr lang="en-US" sz="1050" dirty="0">
+                          <a:solidFill>
+                            <a:srgbClr val="64748B"/>
+                          </a:solidFill>
+                          <a:latin typeface="Calibri" pitchFamily="34" charset="0"/>
+                          <a:ea typeface="Calibri" pitchFamily="34" charset="-122"/>
+                          <a:cs typeface="Calibri" pitchFamily="34" charset="-120"/>
+                        </a:rPr>
+                        <a:t>20 horas inclusas por mês</a:t>
+                      </a:r>
+                      <a:endParaRPr lang="en-US" sz="1200" dirty="0">
+                        <a:latin typeface="Calibri" charset="0"/>
+                        <a:ea typeface="Calibri" charset="0"/>
+                        <a:cs typeface="Calibri" charset="0"/>
+                      </a:endParaRPr>
+                    </a:p>
+                  </a:txBody>
+                  <a:tcPr marL="91440" marR="91440" marT="91440" marB="91440" anchor="ctr">
+                    <a:lnL w="12700" cap="flat" cmpd="sng" algn="ctr">
+                      <a:solidFill>
+                        <a:srgbClr val="E2E8F0"/>
+                      </a:solidFill>
+                      <a:prstDash val="solid"/>
+                      <a:round/>
+                      <a:headEnd type="none" w="med" len="med"/>
+                      <a:tailEnd type="none" w="med" len="med"/>
+                    </a:lnL>
+                    <a:lnR w="12700" cap="flat" cmpd="sng" algn="ctr">
+                      <a:solidFill>
+                        <a:srgbClr val="E2E8F0"/>
+                      </a:solidFill>
+                      <a:prstDash val="solid"/>
+                      <a:round/>
+                      <a:headEnd type="none" w="med" len="med"/>
+                      <a:tailEnd type="none" w="med" len="med"/>
+                    </a:lnR>
+                    <a:lnT w="12700" cap="flat" cmpd="sng" algn="ctr">
+                      <a:solidFill>
+                        <a:srgbClr val="E2E8F0"/>
+                      </a:solidFill>
+                      <a:prstDash val="solid"/>
+                      <a:round/>
+                      <a:headEnd type="none" w="med" len="med"/>
+                      <a:tailEnd type="none" w="med" len="med"/>
+                    </a:lnT>
+                    <a:lnB w="12700" cap="flat" cmpd="sng" algn="ctr">
+                      <a:solidFill>
+                        <a:srgbClr val="E2E8F0"/>
+                      </a:solidFill>
+                      <a:prstDash val="solid"/>
+                      <a:round/>
+                      <a:headEnd type="none" w="med" len="med"/>
+                      <a:tailEnd type="none" w="med" len="med"/>
+                    </a:lnB>
+                    <a:solidFill>
+                      <a:srgbClr val="EFF6FF"/>
+                    </a:solidFill>
+                  </a:tcPr>
+                </a:tc>
+                <a:tc>
+                  <a:txBody>
+                    <a:bodyPr/>
+                    <a:lstStyle/>
+                    <a:p>
+                      <a:pPr algn="ctr" indent="0" marL="0">
+                        <a:buNone/>
+                      </a:pPr>
+                      <a:r>
+                        <a:rPr lang="en-US" sz="1250" b="1" dirty="0">
+                          <a:solidFill>
+                            <a:srgbClr val="101828"/>
+                          </a:solidFill>
+                          <a:latin typeface="Calibri" pitchFamily="34" charset="0"/>
+                          <a:ea typeface="Calibri" pitchFamily="34" charset="-122"/>
+                          <a:cs typeface="Calibri" pitchFamily="34" charset="-120"/>
+                        </a:rPr>
+                        <a:t>R$ 1.875,00/mês</a:t>
+                      </a:r>
+                      <a:endParaRPr lang="en-US" sz="1250" dirty="0">
+                        <a:latin typeface="Calibri" charset="0"/>
+                        <a:ea typeface="Calibri" charset="0"/>
+                        <a:cs typeface="Calibri" charset="0"/>
+                      </a:endParaRPr>
+                    </a:p>
+                  </a:txBody>
+                  <a:tcPr marL="91440" marR="91440" marT="91440" marB="91440" anchor="ctr">
+                    <a:lnL w="12700" cap="flat" cmpd="sng" algn="ctr">
+                      <a:solidFill>
+                        <a:srgbClr val="E2E8F0"/>
+                      </a:solidFill>
+                      <a:prstDash val="solid"/>
+                      <a:round/>
+                      <a:headEnd type="none" w="med" len="med"/>
+                      <a:tailEnd type="none" w="med" len="med"/>
+                    </a:lnL>
+                    <a:lnR w="12700" cap="flat" cmpd="sng" algn="ctr">
+                      <a:solidFill>
+                        <a:srgbClr val="E2E8F0"/>
+                      </a:solidFill>
+                      <a:prstDash val="solid"/>
+                      <a:round/>
+                      <a:headEnd type="none" w="med" len="med"/>
+                      <a:tailEnd type="none" w="med" len="med"/>
+                    </a:lnR>
+                    <a:lnT w="12700" cap="flat" cmpd="sng" algn="ctr">
+                      <a:solidFill>
+                        <a:srgbClr val="E2E8F0"/>
+                      </a:solidFill>
+                      <a:prstDash val="solid"/>
+                      <a:round/>
+                      <a:headEnd type="none" w="med" len="med"/>
+                      <a:tailEnd type="none" w="med" len="med"/>
+                    </a:lnT>
+                    <a:lnB w="12700" cap="flat" cmpd="sng" algn="ctr">
+                      <a:solidFill>
+                        <a:srgbClr val="E2E8F0"/>
+                      </a:solidFill>
+                      <a:prstDash val="solid"/>
+                      <a:round/>
+                      <a:headEnd type="none" w="med" len="med"/>
+                      <a:tailEnd type="none" w="med" len="med"/>
+                    </a:lnB>
+                    <a:solidFill>
+                      <a:srgbClr val="EFF6FF"/>
+                    </a:solidFill>
+                  </a:tcPr>
+                </a:tc>
+                <a:tc>
+                  <a:txBody>
+                    <a:bodyPr/>
+                    <a:lstStyle/>
+                    <a:p>
+                      <a:pPr algn="ctr" indent="0" marL="0">
+                        <a:buNone/>
+                      </a:pPr>
+                      <a:r>
+                        <a:rPr lang="en-US" sz="1400" b="1" dirty="0">
+                          <a:solidFill>
+                            <a:srgbClr val="15803D"/>
+                          </a:solidFill>
+                          <a:latin typeface="Calibri" pitchFamily="34" charset="0"/>
+                          <a:ea typeface="Calibri" pitchFamily="34" charset="-122"/>
+                          <a:cs typeface="Calibri" pitchFamily="34" charset="-120"/>
+                        </a:rPr>
+                        <a:t>R$ 93,75</a:t>
+                      </a:r>
+                      <a:endParaRPr lang="en-US" sz="1400" dirty="0">
+                        <a:latin typeface="Calibri" charset="0"/>
+                        <a:ea typeface="Calibri" charset="0"/>
+                        <a:cs typeface="Calibri" charset="0"/>
+                      </a:endParaRPr>
+                    </a:p>
+                  </a:txBody>
+                  <a:tcPr marL="91440" marR="91440" marT="91440" marB="91440" anchor="ctr">
+                    <a:lnL w="12700" cap="flat" cmpd="sng" algn="ctr">
+                      <a:solidFill>
+                        <a:srgbClr val="E2E8F0"/>
+                      </a:solidFill>
+                      <a:prstDash val="solid"/>
+                      <a:round/>
+                      <a:headEnd type="none" w="med" len="med"/>
+                      <a:tailEnd type="none" w="med" len="med"/>
+                    </a:lnL>
+                    <a:lnR w="12700" cap="flat" cmpd="sng" algn="ctr">
+                      <a:solidFill>
+                        <a:srgbClr val="E2E8F0"/>
+                      </a:solidFill>
+                      <a:prstDash val="solid"/>
+                      <a:round/>
+                      <a:headEnd type="none" w="med" len="med"/>
+                      <a:tailEnd type="none" w="med" len="med"/>
+                    </a:lnR>
+                    <a:lnT w="12700" cap="flat" cmpd="sng" algn="ctr">
+                      <a:solidFill>
+                        <a:srgbClr val="E2E8F0"/>
+                      </a:solidFill>
+                      <a:prstDash val="solid"/>
+                      <a:round/>
+                      <a:headEnd type="none" w="med" len="med"/>
+                      <a:tailEnd type="none" w="med" len="med"/>
+                    </a:lnT>
+                    <a:lnB w="12700" cap="flat" cmpd="sng" algn="ctr">
+                      <a:solidFill>
+                        <a:srgbClr val="E2E8F0"/>
+                      </a:solidFill>
+                      <a:prstDash val="solid"/>
+                      <a:round/>
+                      <a:headEnd type="none" w="med" len="med"/>
+                      <a:tailEnd type="none" w="med" len="med"/>
+                    </a:lnB>
+                    <a:solidFill>
+                      <a:srgbClr val="EFF6FF"/>
+                    </a:solidFill>
+                  </a:tcPr>
+                </a:tc>
+                <a:tc>
+                  <a:txBody>
+                    <a:bodyPr/>
+                    <a:lstStyle/>
+                    <a:p>
+                      <a:pPr algn="ctr" indent="0" marL="0">
+                        <a:buNone/>
+                      </a:pPr>
+                      <a:r>
+                        <a:rPr lang="en-US" sz="1100" b="1" dirty="0">
+                          <a:solidFill>
+                            <a:srgbClr val="1F2937"/>
+                          </a:solidFill>
+                          <a:latin typeface="Calibri" pitchFamily="34" charset="0"/>
+                          <a:ea typeface="Calibri" pitchFamily="34" charset="-122"/>
+                          <a:cs typeface="Calibri" pitchFamily="34" charset="-120"/>
+                        </a:rPr>
+                        <a:t>A partir de 13 horas</a:t>
+                      </a:r>
+                      <a:endParaRPr lang="en-US" sz="1100" dirty="0">
+                        <a:latin typeface="Calibri" charset="0"/>
+                        <a:ea typeface="Calibri" charset="0"/>
+                        <a:cs typeface="Calibri" charset="0"/>
+                      </a:endParaRPr>
+                    </a:p>
+                    <a:p>
+                      <a:pPr algn="ctr" indent="0" marL="0">
+                        <a:buNone/>
+                      </a:pPr>
+                      <a:r>
+                        <a:rPr lang="en-US" sz="1100" b="1" dirty="0">
+                          <a:solidFill>
+                            <a:srgbClr val="1F2937"/>
+                          </a:solidFill>
+                          <a:latin typeface="Calibri" pitchFamily="34" charset="0"/>
+                          <a:ea typeface="Calibri" pitchFamily="34" charset="-122"/>
+                          <a:cs typeface="Calibri" pitchFamily="34" charset="-120"/>
+                        </a:rPr>
+                        <a:t>de uso no mês</a:t>
+                      </a:r>
+                      <a:endParaRPr lang="en-US" sz="1100" dirty="0">
+                        <a:latin typeface="Calibri" charset="0"/>
+                        <a:ea typeface="Calibri" charset="0"/>
+                        <a:cs typeface="Calibri" charset="0"/>
+                      </a:endParaRPr>
+                    </a:p>
+                  </a:txBody>
+                  <a:tcPr marL="91440" marR="91440" marT="91440" marB="91440" anchor="ctr">
+                    <a:lnL w="12700" cap="flat" cmpd="sng" algn="ctr">
+                      <a:solidFill>
+                        <a:srgbClr val="E2E8F0"/>
+                      </a:solidFill>
+                      <a:prstDash val="solid"/>
+                      <a:round/>
+                      <a:headEnd type="none" w="med" len="med"/>
+                      <a:tailEnd type="none" w="med" len="med"/>
+                    </a:lnL>
+                    <a:lnR w="12700" cap="flat" cmpd="sng" algn="ctr">
+                      <a:solidFill>
+                        <a:srgbClr val="E2E8F0"/>
+                      </a:solidFill>
+                      <a:prstDash val="solid"/>
+                      <a:round/>
+                      <a:headEnd type="none" w="med" len="med"/>
+                      <a:tailEnd type="none" w="med" len="med"/>
+                    </a:lnR>
+                    <a:lnT w="12700" cap="flat" cmpd="sng" algn="ctr">
+                      <a:solidFill>
+                        <a:srgbClr val="E2E8F0"/>
+                      </a:solidFill>
+                      <a:prstDash val="solid"/>
+                      <a:round/>
+                      <a:headEnd type="none" w="med" len="med"/>
+                      <a:tailEnd type="none" w="med" len="med"/>
+                    </a:lnT>
+                    <a:lnB w="12700" cap="flat" cmpd="sng" algn="ctr">
+                      <a:solidFill>
+                        <a:srgbClr val="E2E8F0"/>
+                      </a:solidFill>
+                      <a:prstDash val="solid"/>
+                      <a:round/>
+                      <a:headEnd type="none" w="med" len="med"/>
+                      <a:tailEnd type="none" w="med" len="med"/>
+                    </a:lnB>
+                    <a:solidFill>
+                      <a:srgbClr val="EFF6FF"/>
+                    </a:solidFill>
+                  </a:tcPr>
+                </a:tc>
+              </a:tr>
+              <a:tr h="713232">
+                <a:tc>
+                  <a:txBody>
+                    <a:bodyPr/>
+                    <a:lstStyle/>
+                    <a:p>
+                      <a:pPr algn="l" indent="0" marL="0">
+                        <a:buNone/>
+                      </a:pPr>
+                      <a:r>
+                        <a:rPr lang="en-US" sz="1250" b="1" dirty="0">
+                          <a:solidFill>
+                            <a:srgbClr val="101828"/>
+                          </a:solidFill>
+                          <a:latin typeface="Calibri" pitchFamily="34" charset="0"/>
+                          <a:ea typeface="Calibri" pitchFamily="34" charset="-122"/>
+                          <a:cs typeface="Calibri" pitchFamily="34" charset="-120"/>
+                        </a:rPr>
+                        <a:t>Hora avulsa, por demanda
+</a:t>
+                      </a:r>
+                      <a:pPr algn="l" indent="0" marL="0">
+                        <a:buNone/>
+                      </a:pPr>
+                      <a:r>
+                        <a:rPr lang="en-US" sz="1050" dirty="0">
+                          <a:solidFill>
+                            <a:srgbClr val="64748B"/>
+                          </a:solidFill>
+                          <a:latin typeface="Calibri" pitchFamily="34" charset="0"/>
+                          <a:ea typeface="Calibri" pitchFamily="34" charset="-122"/>
+                          <a:cs typeface="Calibri" pitchFamily="34" charset="-120"/>
+                        </a:rPr>
+                        <a:t>sem pacote e sem mensalidade</a:t>
+                      </a:r>
+                      <a:endParaRPr lang="en-US" sz="1200" dirty="0">
+                        <a:latin typeface="Calibri" charset="0"/>
+                        <a:ea typeface="Calibri" charset="0"/>
+                        <a:cs typeface="Calibri" charset="0"/>
+                      </a:endParaRPr>
+                    </a:p>
+                  </a:txBody>
+                  <a:tcPr marL="91440" marR="91440" marT="91440" marB="91440" anchor="ctr">
+                    <a:lnL w="12700" cap="flat" cmpd="sng" algn="ctr">
+                      <a:solidFill>
+                        <a:srgbClr val="E2E8F0"/>
+                      </a:solidFill>
+                      <a:prstDash val="solid"/>
+                      <a:round/>
+                      <a:headEnd type="none" w="med" len="med"/>
+                      <a:tailEnd type="none" w="med" len="med"/>
+                    </a:lnL>
+                    <a:lnR w="12700" cap="flat" cmpd="sng" algn="ctr">
+                      <a:solidFill>
+                        <a:srgbClr val="E2E8F0"/>
+                      </a:solidFill>
+                      <a:prstDash val="solid"/>
+                      <a:round/>
+                      <a:headEnd type="none" w="med" len="med"/>
+                      <a:tailEnd type="none" w="med" len="med"/>
+                    </a:lnR>
+                    <a:lnT w="12700" cap="flat" cmpd="sng" algn="ctr">
+                      <a:solidFill>
+                        <a:srgbClr val="E2E8F0"/>
+                      </a:solidFill>
+                      <a:prstDash val="solid"/>
+                      <a:round/>
+                      <a:headEnd type="none" w="med" len="med"/>
+                      <a:tailEnd type="none" w="med" len="med"/>
+                    </a:lnT>
+                    <a:lnB w="12700" cap="flat" cmpd="sng" algn="ctr">
+                      <a:solidFill>
+                        <a:srgbClr val="E2E8F0"/>
+                      </a:solidFill>
+                      <a:prstDash val="solid"/>
+                      <a:round/>
+                      <a:headEnd type="none" w="med" len="med"/>
+                      <a:tailEnd type="none" w="med" len="med"/>
+                    </a:lnB>
+                    <a:solidFill>
+                      <a:srgbClr val="FFFFFF"/>
+                    </a:solidFill>
+                  </a:tcPr>
+                </a:tc>
+                <a:tc>
+                  <a:txBody>
+                    <a:bodyPr/>
+                    <a:lstStyle/>
+                    <a:p>
+                      <a:pPr algn="ctr" indent="0" marL="0">
+                        <a:buNone/>
+                      </a:pPr>
+                      <a:r>
+                        <a:rPr lang="en-US" sz="1250" b="1" dirty="0">
+                          <a:solidFill>
+                            <a:srgbClr val="101828"/>
+                          </a:solidFill>
+                          <a:latin typeface="Calibri" pitchFamily="34" charset="0"/>
+                          <a:ea typeface="Calibri" pitchFamily="34" charset="-122"/>
+                          <a:cs typeface="Calibri" pitchFamily="34" charset="-120"/>
+                        </a:rPr>
+                        <a:t>R$ 150,00/hora</a:t>
+                      </a:r>
+                      <a:endParaRPr lang="en-US" sz="1250" dirty="0">
+                        <a:latin typeface="Calibri" charset="0"/>
+                        <a:ea typeface="Calibri" charset="0"/>
+                        <a:cs typeface="Calibri" charset="0"/>
+                      </a:endParaRPr>
+                    </a:p>
+                  </a:txBody>
+                  <a:tcPr marL="91440" marR="91440" marT="91440" marB="91440" anchor="ctr">
+                    <a:lnL w="12700" cap="flat" cmpd="sng" algn="ctr">
+                      <a:solidFill>
+                        <a:srgbClr val="E2E8F0"/>
+                      </a:solidFill>
+                      <a:prstDash val="solid"/>
+                      <a:round/>
+                      <a:headEnd type="none" w="med" len="med"/>
+                      <a:tailEnd type="none" w="med" len="med"/>
+                    </a:lnL>
+                    <a:lnR w="12700" cap="flat" cmpd="sng" algn="ctr">
+                      <a:solidFill>
+                        <a:srgbClr val="E2E8F0"/>
+                      </a:solidFill>
+                      <a:prstDash val="solid"/>
+                      <a:round/>
+                      <a:headEnd type="none" w="med" len="med"/>
+                      <a:tailEnd type="none" w="med" len="med"/>
+                    </a:lnR>
+                    <a:lnT w="12700" cap="flat" cmpd="sng" algn="ctr">
+                      <a:solidFill>
+                        <a:srgbClr val="E2E8F0"/>
+                      </a:solidFill>
+                      <a:prstDash val="solid"/>
+                      <a:round/>
+                      <a:headEnd type="none" w="med" len="med"/>
+                      <a:tailEnd type="none" w="med" len="med"/>
+                    </a:lnT>
+                    <a:lnB w="12700" cap="flat" cmpd="sng" algn="ctr">
+                      <a:solidFill>
+                        <a:srgbClr val="E2E8F0"/>
+                      </a:solidFill>
+                      <a:prstDash val="solid"/>
+                      <a:round/>
+                      <a:headEnd type="none" w="med" len="med"/>
+                      <a:tailEnd type="none" w="med" len="med"/>
+                    </a:lnB>
+                    <a:solidFill>
+                      <a:srgbClr val="FFFFFF"/>
+                    </a:solidFill>
+                  </a:tcPr>
+                </a:tc>
+                <a:tc>
+                  <a:txBody>
+                    <a:bodyPr/>
+                    <a:lstStyle/>
+                    <a:p>
+                      <a:pPr algn="ctr" indent="0" marL="0">
+                        <a:buNone/>
+                      </a:pPr>
+                      <a:r>
+                        <a:rPr lang="en-US" sz="1400" b="1" dirty="0">
+                          <a:solidFill>
+                            <a:srgbClr val="1F2937"/>
+                          </a:solidFill>
+                          <a:latin typeface="Calibri" pitchFamily="34" charset="0"/>
+                          <a:ea typeface="Calibri" pitchFamily="34" charset="-122"/>
+                          <a:cs typeface="Calibri" pitchFamily="34" charset="-120"/>
+                        </a:rPr>
+                        <a:t>R$ 150,00</a:t>
+                      </a:r>
+                      <a:endParaRPr lang="en-US" sz="1400" dirty="0">
+                        <a:latin typeface="Calibri" charset="0"/>
+                        <a:ea typeface="Calibri" charset="0"/>
+                        <a:cs typeface="Calibri" charset="0"/>
+                      </a:endParaRPr>
+                    </a:p>
+                  </a:txBody>
+                  <a:tcPr marL="91440" marR="91440" marT="91440" marB="91440" anchor="ctr">
+                    <a:lnL w="12700" cap="flat" cmpd="sng" algn="ctr">
+                      <a:solidFill>
+                        <a:srgbClr val="E2E8F0"/>
+                      </a:solidFill>
+                      <a:prstDash val="solid"/>
+                      <a:round/>
+                      <a:headEnd type="none" w="med" len="med"/>
+                      <a:tailEnd type="none" w="med" len="med"/>
+                    </a:lnL>
+                    <a:lnR w="12700" cap="flat" cmpd="sng" algn="ctr">
+                      <a:solidFill>
+                        <a:srgbClr val="E2E8F0"/>
+                      </a:solidFill>
+                      <a:prstDash val="solid"/>
+                      <a:round/>
+                      <a:headEnd type="none" w="med" len="med"/>
+                      <a:tailEnd type="none" w="med" len="med"/>
+                    </a:lnR>
+                    <a:lnT w="12700" cap="flat" cmpd="sng" algn="ctr">
+                      <a:solidFill>
+                        <a:srgbClr val="E2E8F0"/>
+                      </a:solidFill>
+                      <a:prstDash val="solid"/>
+                      <a:round/>
+                      <a:headEnd type="none" w="med" len="med"/>
+                      <a:tailEnd type="none" w="med" len="med"/>
+                    </a:lnT>
+                    <a:lnB w="12700" cap="flat" cmpd="sng" algn="ctr">
+                      <a:solidFill>
+                        <a:srgbClr val="E2E8F0"/>
+                      </a:solidFill>
+                      <a:prstDash val="solid"/>
+                      <a:round/>
+                      <a:headEnd type="none" w="med" len="med"/>
+                      <a:tailEnd type="none" w="med" len="med"/>
+                    </a:lnB>
+                    <a:solidFill>
+                      <a:srgbClr val="FFFFFF"/>
+                    </a:solidFill>
+                  </a:tcPr>
+                </a:tc>
+                <a:tc>
+                  <a:txBody>
+                    <a:bodyPr/>
+                    <a:lstStyle/>
+                    <a:p>
+                      <a:pPr algn="ctr" indent="0" marL="0">
+                        <a:buNone/>
+                      </a:pPr>
+                      <a:r>
+                        <a:rPr lang="en-US" sz="1100" dirty="0">
+                          <a:solidFill>
+                            <a:srgbClr val="1F2937"/>
+                          </a:solidFill>
+                          <a:latin typeface="Calibri" pitchFamily="34" charset="0"/>
+                          <a:ea typeface="Calibri" pitchFamily="34" charset="-122"/>
+                          <a:cs typeface="Calibri" pitchFamily="34" charset="-120"/>
+                        </a:rPr>
+                        <a:t>Uso eventual, abaixo</a:t>
+                      </a:r>
+                      <a:endParaRPr lang="en-US" sz="1100" dirty="0">
+                        <a:latin typeface="Calibri" charset="0"/>
+                        <a:ea typeface="Calibri" charset="0"/>
+                        <a:cs typeface="Calibri" charset="0"/>
+                      </a:endParaRPr>
+                    </a:p>
+                    <a:p>
+                      <a:pPr algn="ctr" indent="0" marL="0">
+                        <a:buNone/>
+                      </a:pPr>
+                      <a:r>
+                        <a:rPr lang="en-US" sz="1100" dirty="0">
+                          <a:solidFill>
+                            <a:srgbClr val="1F2937"/>
+                          </a:solidFill>
+                          <a:latin typeface="Calibri" pitchFamily="34" charset="0"/>
+                          <a:ea typeface="Calibri" pitchFamily="34" charset="-122"/>
+                          <a:cs typeface="Calibri" pitchFamily="34" charset="-120"/>
+                        </a:rPr>
+                        <a:t>de 12 horas no mês</a:t>
+                      </a:r>
+                      <a:endParaRPr lang="en-US" sz="1100" dirty="0">
+                        <a:latin typeface="Calibri" charset="0"/>
+                        <a:ea typeface="Calibri" charset="0"/>
+                        <a:cs typeface="Calibri" charset="0"/>
+                      </a:endParaRPr>
+                    </a:p>
+                  </a:txBody>
+                  <a:tcPr marL="91440" marR="91440" marT="91440" marB="91440" anchor="ctr">
+                    <a:lnL w="12700" cap="flat" cmpd="sng" algn="ctr">
+                      <a:solidFill>
+                        <a:srgbClr val="E2E8F0"/>
+                      </a:solidFill>
+                      <a:prstDash val="solid"/>
+                      <a:round/>
+                      <a:headEnd type="none" w="med" len="med"/>
+                      <a:tailEnd type="none" w="med" len="med"/>
+                    </a:lnL>
+                    <a:lnR w="12700" cap="flat" cmpd="sng" algn="ctr">
+                      <a:solidFill>
+                        <a:srgbClr val="E2E8F0"/>
+                      </a:solidFill>
+                      <a:prstDash val="solid"/>
+                      <a:round/>
+                      <a:headEnd type="none" w="med" len="med"/>
+                      <a:tailEnd type="none" w="med" len="med"/>
+                    </a:lnR>
+                    <a:lnT w="12700" cap="flat" cmpd="sng" algn="ctr">
+                      <a:solidFill>
+                        <a:srgbClr val="E2E8F0"/>
+                      </a:solidFill>
+                      <a:prstDash val="solid"/>
+                      <a:round/>
+                      <a:headEnd type="none" w="med" len="med"/>
+                      <a:tailEnd type="none" w="med" len="med"/>
+                    </a:lnT>
+                    <a:lnB w="12700" cap="flat" cmpd="sng" algn="ctr">
+                      <a:solidFill>
+                        <a:srgbClr val="E2E8F0"/>
+                      </a:solidFill>
+                      <a:prstDash val="solid"/>
+                      <a:round/>
+                      <a:headEnd type="none" w="med" len="med"/>
+                      <a:tailEnd type="none" w="med" len="med"/>
+                    </a:lnB>
+                    <a:solidFill>
+                      <a:srgbClr val="FFFFFF"/>
+                    </a:solidFill>
+                  </a:tcPr>
+                </a:tc>
+              </a:tr>
+            </a:tbl>
+          </a:graphicData>
+        </a:graphic>
+      </p:graphicFrame>
+      <p:sp>
+        <p:nvSpPr>
+          <p:cNvPr id="5" name="Shape 2"/>
+          <p:cNvSpPr/>
+          <p:nvPr/>
+        </p:nvSpPr>
+        <p:spPr>
+          <a:xfrm>
+            <a:off x="548640" y="3438144"/>
+            <a:ext cx="11094415" cy="512064"/>
+          </a:xfrm>
+          <a:prstGeom prst="roundRect">
+            <a:avLst>
+              <a:gd name="adj" fmla="val 10714"/>
+            </a:avLst>
+          </a:prstGeom>
+          <a:solidFill>
+            <a:srgbClr val="ECFDF3"/>
+          </a:solidFill>
+          <a:ln w="12700">
+            <a:solidFill>
+              <a:srgbClr val="A7F3D0"/>
+            </a:solidFill>
+            <a:prstDash val="solid"/>
+          </a:ln>
+        </p:spPr>
+      </p:sp>
+      <p:sp>
+        <p:nvSpPr>
+          <p:cNvPr id="6" name="Text 3"/>
+          <p:cNvSpPr/>
+          <p:nvPr/>
+        </p:nvSpPr>
+        <p:spPr>
+          <a:xfrm>
+            <a:off x="786384" y="3438144"/>
+            <a:ext cx="10618927" cy="512064"/>
+          </a:xfrm>
+          <a:prstGeom prst="rect">
+            <a:avLst/>
+          </a:prstGeom>
+          <a:noFill/>
+          <a:ln/>
+        </p:spPr>
+        <p:txBody>
+          <a:bodyPr wrap="square" rtlCol="0" anchor="ctr"/>
+          <a:lstStyle/>
+          <a:p>
+            <a:pPr indent="0" marL="0">
+              <a:buNone/>
+            </a:pPr>
+            <a:r>
+              <a:rPr lang="en-US" sz="1200" b="1" dirty="0">
+                <a:solidFill>
+                  <a:srgbClr val="15803D"/>
+                </a:solidFill>
+                <a:latin typeface="Calibri" pitchFamily="34" charset="0"/>
+                <a:ea typeface="Calibri" pitchFamily="34" charset="-122"/>
+                <a:cs typeface="Calibri" pitchFamily="34" charset="-120"/>
+              </a:rPr>
+              <a:t>O pacote sai 37,5% mais barato por hora</a:t>
+            </a:r>
+            <a:pPr indent="0" marL="0">
+              <a:buNone/>
+            </a:pPr>
+            <a:r>
+              <a:rPr lang="en-US" sz="1200" dirty="0">
+                <a:solidFill>
+                  <a:srgbClr val="1F2937"/>
+                </a:solidFill>
+                <a:latin typeface="Calibri" pitchFamily="34" charset="0"/>
+                <a:ea typeface="Calibri" pitchFamily="34" charset="-122"/>
+                <a:cs typeface="Calibri" pitchFamily="34" charset="-120"/>
+              </a:rPr>
+              <a:t>: as mesmas 20 horas avulsas custariam R$ 3.000,00. O ponto de equilíbrio fica em 12,5 horas por mês.</a:t>
+            </a:r>
+            <a:endParaRPr lang="en-US" sz="1200" dirty="0"/>
+          </a:p>
+        </p:txBody>
+      </p:sp>
+      <p:sp>
+        <p:nvSpPr>
+          <p:cNvPr id="7" name="Shape 4"/>
+          <p:cNvSpPr/>
+          <p:nvPr/>
+        </p:nvSpPr>
+        <p:spPr>
+          <a:xfrm>
+            <a:off x="548640" y="4133088"/>
+            <a:ext cx="5410048" cy="2029968"/>
+          </a:xfrm>
+          <a:prstGeom prst="roundRect">
+            <a:avLst>
+              <a:gd name="adj" fmla="val 3153"/>
+            </a:avLst>
+          </a:prstGeom>
+          <a:solidFill>
+            <a:srgbClr val="FFFFFF"/>
+          </a:solidFill>
+          <a:ln w="12700">
+            <a:solidFill>
+              <a:srgbClr val="E2E8F0"/>
+            </a:solidFill>
+            <a:prstDash val="solid"/>
+          </a:ln>
+        </p:spPr>
+      </p:sp>
+      <p:sp>
+        <p:nvSpPr>
+          <p:cNvPr id="8" name="Text 5"/>
+          <p:cNvSpPr/>
+          <p:nvPr/>
+        </p:nvSpPr>
+        <p:spPr>
+          <a:xfrm>
+            <a:off x="822960" y="4315968"/>
+            <a:ext cx="4861408" cy="256032"/>
+          </a:xfrm>
+          <a:prstGeom prst="rect">
+            <a:avLst/>
+          </a:prstGeom>
+          <a:noFill/>
+          <a:ln/>
+        </p:spPr>
+        <p:txBody>
+          <a:bodyPr wrap="square" rtlCol="0" anchor="ctr"/>
+          <a:lstStyle/>
+          <a:p>
+            <a:pPr indent="0" marL="0">
+              <a:buNone/>
+            </a:pPr>
+            <a:r>
+              <a:rPr lang="en-US" sz="1050" b="1" spc="100" kern="0" dirty="0">
+                <a:solidFill>
+                  <a:srgbClr val="64748B"/>
+                </a:solidFill>
+                <a:latin typeface="Calibri" pitchFamily="34" charset="0"/>
+                <a:ea typeface="Calibri" pitchFamily="34" charset="-122"/>
+                <a:cs typeface="Calibri" pitchFamily="34" charset="-120"/>
+              </a:rPr>
+              <a:t>COMO AS HORAS FUNCIONAM</a:t>
+            </a:r>
+            <a:endParaRPr lang="en-US" sz="1050" dirty="0"/>
+          </a:p>
+        </p:txBody>
+      </p:sp>
+      <p:sp>
+        <p:nvSpPr>
+          <p:cNvPr id="9" name="Text 6"/>
+          <p:cNvSpPr/>
+          <p:nvPr/>
+        </p:nvSpPr>
+        <p:spPr>
+          <a:xfrm>
+            <a:off x="822960" y="4626864"/>
+            <a:ext cx="4861408" cy="1371600"/>
+          </a:xfrm>
+          <a:prstGeom prst="rect">
+            <a:avLst/>
+          </a:prstGeom>
+          <a:noFill/>
+          <a:ln/>
+        </p:spPr>
+        <p:txBody>
+          <a:bodyPr wrap="square" rtlCol="0" anchor="t"/>
+          <a:lstStyle/>
+          <a:p>
+            <a:pPr marL="342900" indent="-342900">
+              <a:lnSpc>
+                <a:spcPct val="130000"/>
+              </a:lnSpc>
+              <a:buSzPct val="100000"/>
+              <a:buChar char="•"/>
+            </a:pPr>
+            <a:r>
+              <a:rPr lang="en-US" sz="1150" dirty="0">
+                <a:solidFill>
+                  <a:srgbClr val="1F2937"/>
+                </a:solidFill>
+                <a:latin typeface="Calibri" pitchFamily="34" charset="0"/>
+                <a:ea typeface="Calibri" pitchFamily="34" charset="-122"/>
+                <a:cs typeface="Calibri" pitchFamily="34" charset="-120"/>
+              </a:rPr>
+              <a:t>Correção de defeito não consome hora: é obrigação da ARV LABS</a:t>
+            </a:r>
+            <a:endParaRPr lang="en-US" sz="1150" dirty="0"/>
+          </a:p>
+          <a:p>
+            <a:pPr marL="342900" indent="-342900">
+              <a:lnSpc>
+                <a:spcPct val="130000"/>
+              </a:lnSpc>
+              <a:buSzPct val="100000"/>
+              <a:buChar char="•"/>
+            </a:pPr>
+            <a:r>
+              <a:rPr lang="en-US" sz="1150" dirty="0">
+                <a:solidFill>
+                  <a:srgbClr val="1F2937"/>
+                </a:solidFill>
+                <a:latin typeface="Calibri" pitchFamily="34" charset="0"/>
+                <a:ea typeface="Calibri" pitchFamily="34" charset="-122"/>
+                <a:cs typeface="Calibri" pitchFamily="34" charset="-120"/>
+              </a:rPr>
+              <a:t>Atualização de segurança também não consome hora</a:t>
+            </a:r>
+            <a:endParaRPr lang="en-US" sz="1150" dirty="0"/>
+          </a:p>
+          <a:p>
+            <a:pPr marL="342900" indent="-342900">
+              <a:lnSpc>
+                <a:spcPct val="130000"/>
+              </a:lnSpc>
+              <a:buSzPct val="100000"/>
+              <a:buChar char="•"/>
+            </a:pPr>
+            <a:r>
+              <a:rPr lang="en-US" sz="1150" dirty="0">
+                <a:solidFill>
+                  <a:srgbClr val="1F2937"/>
+                </a:solidFill>
+                <a:latin typeface="Calibri" pitchFamily="34" charset="0"/>
+                <a:ea typeface="Calibri" pitchFamily="34" charset="-122"/>
+                <a:cs typeface="Calibri" pitchFamily="34" charset="-120"/>
+              </a:rPr>
+              <a:t>As horas valem para melhorias: campos, relatórios, regras e telas</a:t>
+            </a:r>
+            <a:endParaRPr lang="en-US" sz="1150" dirty="0"/>
+          </a:p>
+          <a:p>
+            <a:pPr marL="342900" indent="-342900">
+              <a:lnSpc>
+                <a:spcPct val="130000"/>
+              </a:lnSpc>
+              <a:buSzPct val="100000"/>
+              <a:buChar char="•"/>
+            </a:pPr>
+            <a:r>
+              <a:rPr lang="en-US" sz="1150" dirty="0">
+                <a:solidFill>
+                  <a:srgbClr val="1F2937"/>
+                </a:solidFill>
+                <a:latin typeface="Calibri" pitchFamily="34" charset="0"/>
+                <a:ea typeface="Calibri" pitchFamily="34" charset="-122"/>
+                <a:cs typeface="Calibri" pitchFamily="34" charset="-120"/>
+              </a:rPr>
+              <a:t>Toda demanda é estimada e aprovada antes de começar</a:t>
+            </a:r>
+            <a:endParaRPr lang="en-US" sz="1150" dirty="0"/>
+          </a:p>
+        </p:txBody>
+      </p:sp>
+      <p:sp>
+        <p:nvSpPr>
+          <p:cNvPr id="10" name="Shape 7"/>
+          <p:cNvSpPr/>
+          <p:nvPr/>
+        </p:nvSpPr>
+        <p:spPr>
+          <a:xfrm>
+            <a:off x="6233008" y="4133088"/>
+            <a:ext cx="5410048" cy="2029968"/>
+          </a:xfrm>
+          <a:prstGeom prst="roundRect">
+            <a:avLst>
+              <a:gd name="adj" fmla="val 3153"/>
+            </a:avLst>
+          </a:prstGeom>
+          <a:solidFill>
+            <a:srgbClr val="FFFFFF"/>
+          </a:solidFill>
+          <a:ln w="12700">
+            <a:solidFill>
+              <a:srgbClr val="A7F3D0"/>
+            </a:solidFill>
+            <a:prstDash val="solid"/>
+          </a:ln>
+        </p:spPr>
+      </p:sp>
+      <p:sp>
+        <p:nvSpPr>
+          <p:cNvPr id="11" name="Text 8"/>
+          <p:cNvSpPr/>
+          <p:nvPr/>
+        </p:nvSpPr>
+        <p:spPr>
+          <a:xfrm>
+            <a:off x="6507328" y="4315968"/>
+            <a:ext cx="4861408" cy="256032"/>
+          </a:xfrm>
+          <a:prstGeom prst="rect">
+            <a:avLst/>
+          </a:prstGeom>
+          <a:noFill/>
+          <a:ln/>
+        </p:spPr>
+        <p:txBody>
+          <a:bodyPr wrap="square" rtlCol="0" anchor="ctr"/>
+          <a:lstStyle/>
+          <a:p>
+            <a:pPr indent="0" marL="0">
+              <a:buNone/>
+            </a:pPr>
+            <a:r>
+              <a:rPr lang="en-US" sz="1050" b="1" spc="100" kern="0" dirty="0">
+                <a:solidFill>
+                  <a:srgbClr val="64748B"/>
+                </a:solidFill>
+                <a:latin typeface="Calibri" pitchFamily="34" charset="0"/>
+                <a:ea typeface="Calibri" pitchFamily="34" charset="-122"/>
+                <a:cs typeface="Calibri" pitchFamily="34" charset="-120"/>
+              </a:rPr>
+              <a:t>VALE PARA OS DOIS MODELOS</a:t>
+            </a:r>
+            <a:endParaRPr lang="en-US" sz="1050" dirty="0"/>
+          </a:p>
+        </p:txBody>
+      </p:sp>
+      <p:sp>
+        <p:nvSpPr>
+          <p:cNvPr id="12" name="Text 9"/>
+          <p:cNvSpPr/>
+          <p:nvPr/>
+        </p:nvSpPr>
+        <p:spPr>
+          <a:xfrm>
+            <a:off x="6507328" y="4626864"/>
+            <a:ext cx="4861408" cy="1371600"/>
+          </a:xfrm>
+          <a:prstGeom prst="rect">
+            <a:avLst/>
+          </a:prstGeom>
+          <a:noFill/>
+          <a:ln/>
+        </p:spPr>
+        <p:txBody>
+          <a:bodyPr wrap="square" rtlCol="0" anchor="t"/>
+          <a:lstStyle/>
+          <a:p>
+            <a:pPr marL="342900" indent="-342900">
+              <a:lnSpc>
+                <a:spcPct val="130000"/>
+              </a:lnSpc>
+              <a:buSzPct val="100000"/>
+              <a:buChar char="•"/>
+            </a:pPr>
+            <a:r>
+              <a:rPr lang="en-US" sz="1150" dirty="0">
+                <a:solidFill>
+                  <a:srgbClr val="1F2937"/>
+                </a:solidFill>
+                <a:latin typeface="Calibri" pitchFamily="34" charset="0"/>
+                <a:ea typeface="Calibri" pitchFamily="34" charset="-122"/>
+                <a:cs typeface="Calibri" pitchFamily="34" charset="-120"/>
+              </a:rPr>
+              <a:t>Na assinatura, as 20 horas já estão inclusas nos R$ 1.980,00</a:t>
+            </a:r>
+            <a:endParaRPr lang="en-US" sz="1150" dirty="0"/>
+          </a:p>
+          <a:p>
+            <a:pPr marL="342900" indent="-342900">
+              <a:lnSpc>
+                <a:spcPct val="130000"/>
+              </a:lnSpc>
+              <a:buSzPct val="100000"/>
+              <a:buChar char="•"/>
+            </a:pPr>
+            <a:r>
+              <a:rPr lang="en-US" sz="1150" dirty="0">
+                <a:solidFill>
+                  <a:srgbClr val="1F2937"/>
+                </a:solidFill>
+                <a:latin typeface="Calibri" pitchFamily="34" charset="0"/>
+                <a:ea typeface="Calibri" pitchFamily="34" charset="-122"/>
+                <a:cs typeface="Calibri" pitchFamily="34" charset="-120"/>
+              </a:rPr>
+              <a:t>Na aquisição, vêm no pacote de manutenção de R$ 1.875,00</a:t>
+            </a:r>
+            <a:endParaRPr lang="en-US" sz="1150" dirty="0"/>
+          </a:p>
+          <a:p>
+            <a:pPr marL="342900" indent="-342900">
+              <a:lnSpc>
+                <a:spcPct val="130000"/>
+              </a:lnSpc>
+              <a:buSzPct val="100000"/>
+              <a:buChar char="•"/>
+            </a:pPr>
+            <a:r>
+              <a:rPr lang="en-US" sz="1150" dirty="0">
+                <a:solidFill>
+                  <a:srgbClr val="1F2937"/>
+                </a:solidFill>
+                <a:latin typeface="Calibri" pitchFamily="34" charset="0"/>
+                <a:ea typeface="Calibri" pitchFamily="34" charset="-122"/>
+                <a:cs typeface="Calibri" pitchFamily="34" charset="-120"/>
+              </a:rPr>
+              <a:t>Em ambos, a hora além do pacote é cobrada a R$ 150,00</a:t>
+            </a:r>
+            <a:endParaRPr lang="en-US" sz="1150" dirty="0"/>
+          </a:p>
+          <a:p>
+            <a:pPr marL="342900" indent="-342900">
+              <a:lnSpc>
+                <a:spcPct val="130000"/>
+              </a:lnSpc>
+              <a:buSzPct val="100000"/>
+              <a:buChar char="•"/>
+            </a:pPr>
+            <a:r>
+              <a:rPr lang="en-US" sz="1150" dirty="0">
+                <a:solidFill>
+                  <a:srgbClr val="1F2937"/>
+                </a:solidFill>
+                <a:latin typeface="Calibri" pitchFamily="34" charset="0"/>
+                <a:ea typeface="Calibri" pitchFamily="34" charset="-122"/>
+                <a:cs typeface="Calibri" pitchFamily="34" charset="-120"/>
+              </a:rPr>
+              <a:t>Horas não utilizadas não acumulam para o mês seguinte</a:t>
+            </a:r>
+            <a:endParaRPr lang="en-US" sz="1150" dirty="0"/>
           </a:p>
         </p:txBody>
       </p:sp>

</xml_diff>